<commit_message>
Update .gitignore: exclude Office temp files, exported slides, PDFs
Co-Authored-By: Claude Opus 4.6 (1M context) <noreply@anthropic.com>
</commit_message>
<xml_diff>
--- a/Migration-Agent-Architecture-Options.pptx
+++ b/Migration-Agent-Architecture-Options.pptx
@@ -2809,7 +2809,7 @@
                 <a:ea typeface="Calibri" pitchFamily="34" charset="-122"/>
                 <a:cs typeface="Calibri" pitchFamily="34" charset="-120"/>
               </a:rPr>
-              <a:t>api.py (380 lines)</a:t>
+              <a:t>(thin wrapper)</a:t>
             </a:r>
             <a:endParaRPr lang="en-US" sz="750" dirty="0"/>
           </a:p>
@@ -2896,7 +2896,7 @@
                 <a:ea typeface="Calibri" pitchFamily="34" charset="-122"/>
                 <a:cs typeface="Calibri" pitchFamily="34" charset="-120"/>
               </a:rPr>
-              <a:t>codex --full-auto --model o4-mini</a:t>
+              <a:t>codex --full-auto --model gpt-5.3-codex</a:t>
             </a:r>
             <a:endParaRPr lang="en-US" sz="750" dirty="0"/>
           </a:p>
@@ -3602,7 +3602,7 @@
                 <a:ea typeface="Calibri" pitchFamily="34" charset="-122"/>
                 <a:cs typeface="Calibri" pitchFamily="34" charset="-120"/>
               </a:rPr>
-              <a:t>(o4-mini, codex-mini)</a:t>
+              <a:t>(gpt-5.3-codex)</a:t>
             </a:r>
             <a:endParaRPr lang="en-US" sz="800" dirty="0"/>
           </a:p>
@@ -4274,7 +4274,7 @@
                 <a:ea typeface="Calibri" pitchFamily="34" charset="-122"/>
                 <a:cs typeface="Calibri" pitchFamily="34" charset="-120"/>
               </a:rPr>
-              <a:t>api.py (180 lines)</a:t>
+              <a:t>(thin API wrapper)</a:t>
             </a:r>
             <a:endParaRPr lang="en-US" sz="750" dirty="0"/>
           </a:p>
@@ -4341,7 +4341,7 @@
                 <a:ea typeface="Calibri" pitchFamily="34" charset="-122"/>
                 <a:cs typeface="Calibri" pitchFamily="34" charset="-120"/>
               </a:rPr>
-              <a:t>pipeline.py (248 lines)</a:t>
+              <a:t>Custom Pipeline (High effort)</a:t>
             </a:r>
             <a:endParaRPr lang="en-US" sz="750" dirty="0"/>
           </a:p>
@@ -4361,7 +4361,7 @@
                 <a:ea typeface="Calibri" pitchFamily="34" charset="-122"/>
                 <a:cs typeface="Calibri" pitchFamily="34" charset="-120"/>
               </a:rPr>
-              <a:t>Custom 6-gate orchestration</a:t>
+              <a:t>6-gate orchestration</a:t>
             </a:r>
             <a:endParaRPr lang="en-US" sz="750" dirty="0"/>
           </a:p>
@@ -4533,7 +4533,7 @@
                 <a:ea typeface="Calibri" pitchFamily="34" charset="-122"/>
                 <a:cs typeface="Calibri" pitchFamily="34" charset="-120"/>
               </a:rPr>
-              <a:t>(99 lines)</a:t>
+              <a:t>(Custom)</a:t>
             </a:r>
             <a:endParaRPr lang="en-US" sz="800" dirty="0"/>
           </a:p>
@@ -4622,7 +4622,7 @@
                 <a:ea typeface="Calibri" pitchFamily="34" charset="-122"/>
                 <a:cs typeface="Calibri" pitchFamily="34" charset="-120"/>
               </a:rPr>
-              <a:t>(184 lines)</a:t>
+              <a:t>(Custom)</a:t>
             </a:r>
             <a:endParaRPr lang="en-US" sz="800" dirty="0"/>
           </a:p>
@@ -4711,7 +4711,7 @@
                 <a:ea typeface="Calibri" pitchFamily="34" charset="-122"/>
                 <a:cs typeface="Calibri" pitchFamily="34" charset="-120"/>
               </a:rPr>
-              <a:t>(239 lines)</a:t>
+              <a:t>(Custom)</a:t>
             </a:r>
             <a:endParaRPr lang="en-US" sz="800" dirty="0"/>
           </a:p>
@@ -4800,7 +4800,7 @@
                 <a:ea typeface="Calibri" pitchFamily="34" charset="-122"/>
                 <a:cs typeface="Calibri" pitchFamily="34" charset="-120"/>
               </a:rPr>
-              <a:t>(173 lines)</a:t>
+              <a:t>(Custom)</a:t>
             </a:r>
             <a:endParaRPr lang="en-US" sz="800" dirty="0"/>
           </a:p>
@@ -4867,7 +4867,7 @@
                 <a:ea typeface="Calibri" pitchFamily="34" charset="-122"/>
                 <a:cs typeface="Calibri" pitchFamily="34" charset="-120"/>
               </a:rPr>
-              <a:t>Context Engine (419 lines)</a:t>
+              <a:t>Context Engine (High effort)</a:t>
             </a:r>
             <a:endParaRPr lang="en-US" sz="650" dirty="0"/>
           </a:p>
@@ -4954,7 +4954,7 @@
                 <a:ea typeface="Calibri" pitchFamily="34" charset="-122"/>
                 <a:cs typeface="Calibri" pitchFamily="34" charset="-120"/>
               </a:rPr>
-              <a:t>Custom Tools (385 lines)</a:t>
+              <a:t>Custom Tools (High effort)</a:t>
             </a:r>
             <a:endParaRPr lang="en-US" sz="650" dirty="0"/>
           </a:p>
@@ -5154,7 +5154,7 @@
                 <a:ea typeface="Calibri" pitchFamily="34" charset="-122"/>
                 <a:cs typeface="Calibri" pitchFamily="34" charset="-120"/>
               </a:rPr>
-              <a:t>(gpt-4o)</a:t>
+              <a:t>(gpt-4o / gpt-4o-mini)</a:t>
             </a:r>
             <a:endParaRPr lang="en-US" sz="800" dirty="0"/>
           </a:p>
@@ -7154,7 +7154,7 @@
                 <a:ea typeface="Calibri" pitchFamily="34" charset="-122"/>
                 <a:cs typeface="Calibri" pitchFamily="34" charset="-120"/>
               </a:rPr>
-              <a:t>888 lines Python + 525 TOML</a:t>
+              <a:t>Low (thin wrapper + config)</a:t>
             </a:r>
             <a:endParaRPr lang="en-US" sz="1000" dirty="0"/>
           </a:p>
@@ -7213,7 +7213,7 @@
                 <a:ea typeface="Calibri" pitchFamily="34" charset="-122"/>
                 <a:cs typeface="Calibri" pitchFamily="34" charset="-120"/>
               </a:rPr>
-              <a:t>2,394 lines Python</a:t>
+              <a:t>High (all custom Python)</a:t>
             </a:r>
             <a:endParaRPr lang="en-US" sz="1000" dirty="0"/>
           </a:p>
@@ -7331,7 +7331,7 @@
                 <a:ea typeface="Calibri" pitchFamily="34" charset="-122"/>
                 <a:cs typeface="Calibri" pitchFamily="34" charset="-120"/>
               </a:rPr>
-              <a:t>359 lines (4 modules)</a:t>
+              <a:t>Low (4 modules)</a:t>
             </a:r>
             <a:endParaRPr lang="en-US" sz="1000" dirty="0"/>
           </a:p>
@@ -7390,7 +7390,7 @@
                 <a:ea typeface="Calibri" pitchFamily="34" charset="-122"/>
                 <a:cs typeface="Calibri" pitchFamily="34" charset="-120"/>
               </a:rPr>
-              <a:t>1,119 lines (9 modules)</a:t>
+              <a:t>High (9 modules)</a:t>
             </a:r>
             <a:endParaRPr lang="en-US" sz="1000" dirty="0"/>
           </a:p>
@@ -7744,7 +7744,7 @@
                 <a:ea typeface="Calibri" pitchFamily="34" charset="-122"/>
                 <a:cs typeface="Calibri" pitchFamily="34" charset="-120"/>
               </a:rPr>
-              <a:t>Maintain 2,394-line codebase</a:t>
+              <a:t>Maintain large custom codebase</a:t>
             </a:r>
             <a:endParaRPr lang="en-US" sz="1000" dirty="0"/>
           </a:p>
@@ -7968,7 +7968,7 @@
                 <a:ea typeface="Calibri" pitchFamily="34" charset="-122"/>
                 <a:cs typeface="Calibri" pitchFamily="34" charset="-120"/>
               </a:rPr>
-              <a:t>Both approaches were implemented and tested. Codex provides sub-agent runtime, sandboxing, context engine, and tools as platform features — you write config. MS Agent Framework requires hand-building all of these. Codex Harness: 888 lines code + 1,360 config. MS Harness: 2,394 lines code.</a:t>
+              <a:t>Both approaches were implemented and tested. Codex provides sub-agent runtime, sandboxing, context engine, and tools as platform features — you write config. MS Agent Framework requires hand-building all of these. Codex Harness: Low effort (mostly config). MS Harness: High effort (all custom Python).</a:t>
             </a:r>
             <a:endParaRPr lang="en-US" sz="1200" dirty="0"/>
           </a:p>
@@ -8101,7 +8101,7 @@
                 <a:ea typeface="Calibri" pitchFamily="34" charset="-122"/>
                 <a:cs typeface="Calibri" pitchFamily="34" charset="-120"/>
               </a:rPr>
-              <a:t>Codex provides sandboxing, context compaction, tools (ripgrep, tree-sitter), and agent isolation as built-in features. MS Agent FW requires 804 lines of custom code for these same capabilities.</a:t>
+              <a:t>Codex provides sandboxing, context compaction, tools (ripgrep, tree-sitter), and agent isolation as built-in features. MS Agent FW requires high-effort custom code for these same capabilities.</a:t>
             </a:r>
             <a:endParaRPr lang="en-US" sz="1000" dirty="0"/>
           </a:p>
@@ -8192,7 +8192,7 @@
                 <a:ea typeface="Trebuchet MS" pitchFamily="34" charset="-122"/>
                 <a:cs typeface="Trebuchet MS" pitchFamily="34" charset="-120"/>
               </a:rPr>
-              <a:t>2.7x Less Custom Code</a:t>
+              <a:t>Dramatically Less Custom Code</a:t>
             </a:r>
             <a:endParaRPr lang="en-US" sz="1400" dirty="0"/>
           </a:p>
@@ -8234,7 +8234,7 @@
                 <a:ea typeface="Calibri" pitchFamily="34" charset="-122"/>
                 <a:cs typeface="Calibri" pitchFamily="34" charset="-120"/>
               </a:rPr>
-              <a:t>888 lines production Python vs 2,394 lines. Lower defect surface, easier to audit, cheaper to maintain. 36% of Codex codebase is declarative config — not imperative code.</a:t>
+              <a:t>Codex: Low effort (thin wrapper + declarative config). MS Agent FW: High effort (all custom Python). Lower defect surface, easier to audit, cheaper to maintain.</a:t>
             </a:r>
             <a:endParaRPr lang="en-US" sz="1000" dirty="0"/>
           </a:p>
@@ -10896,7 +10896,7 @@
                 <a:ea typeface="Calibri" pitchFamily="34" charset="-122"/>
                 <a:cs typeface="Calibri" pitchFamily="34" charset="-120"/>
               </a:rPr>
-              <a:t>o4 (reasoning)</a:t>
+              <a:t>gpt-5.3-codex</a:t>
             </a:r>
             <a:endParaRPr lang="en-US" sz="900" dirty="0"/>
           </a:p>
@@ -11147,7 +11147,7 @@
                 <a:ea typeface="Calibri" pitchFamily="34" charset="-122"/>
                 <a:cs typeface="Calibri" pitchFamily="34" charset="-120"/>
               </a:rPr>
-              <a:t>codex-mini</a:t>
+              <a:t>gpt-5.3-codex</a:t>
             </a:r>
             <a:endParaRPr lang="en-US" sz="900" dirty="0"/>
           </a:p>
@@ -11398,7 +11398,7 @@
                 <a:ea typeface="Calibri" pitchFamily="34" charset="-122"/>
                 <a:cs typeface="Calibri" pitchFamily="34" charset="-120"/>
               </a:rPr>
-              <a:t>o4-mini</a:t>
+              <a:t>gpt-5.3-codex</a:t>
             </a:r>
             <a:endParaRPr lang="en-US" sz="900" dirty="0"/>
           </a:p>
@@ -11649,7 +11649,7 @@
                 <a:ea typeface="Calibri" pitchFamily="34" charset="-122"/>
                 <a:cs typeface="Calibri" pitchFamily="34" charset="-120"/>
               </a:rPr>
-              <a:t>o4 (reasoning)</a:t>
+              <a:t>gpt-5.3-codex</a:t>
             </a:r>
             <a:endParaRPr lang="en-US" sz="900" dirty="0"/>
           </a:p>
@@ -11809,7 +11809,7 @@
                 <a:ea typeface="Calibri" pitchFamily="34" charset="-122"/>
                 <a:cs typeface="Calibri" pitchFamily="34" charset="-120"/>
               </a:rPr>
-              <a:t>Total: 3,757 lines  |  36% declarative config (TOML/MD)  |  Agents run INSIDE Codex sandboxes</a:t>
+              <a:t>Effort: Low (mostly config)  |  Declarative TOML/MD  |  Agents run INSIDE Codex sandboxes</a:t>
             </a:r>
             <a:endParaRPr lang="en-US" sz="1100" dirty="0"/>
           </a:p>
@@ -12033,7 +12033,7 @@
                 <a:ea typeface="Calibri" pitchFamily="34" charset="-122"/>
                 <a:cs typeface="Calibri" pitchFamily="34" charset="-120"/>
               </a:rPr>
-              <a:t>140-line root AGENTS.md + per-language overrides + program.md steering doc. Codex loads hierarchically. Human can edit program.md mid-run.</a:t>
+              <a:t>Root AGENTS.md + per-language overrides + program.md steering doc. Codex loads hierarchically. Human can edit program.md mid-run.</a:t>
             </a:r>
             <a:endParaRPr lang="en-US" sz="1000" dirty="0"/>
           </a:p>
@@ -12124,7 +12124,7 @@
                 <a:ea typeface="Trebuchet MS" pitchFamily="34" charset="-122"/>
                 <a:cs typeface="Trebuchet MS" pitchFamily="34" charset="-120"/>
               </a:rPr>
-              <a:t>TOML Sub-Agents (525 lines)</a:t>
+              <a:t>TOML Sub-Agents</a:t>
             </a:r>
             <a:endParaRPr lang="en-US" sz="1300" dirty="0"/>
           </a:p>
@@ -12166,7 +12166,7 @@
                 <a:ea typeface="Calibri" pitchFamily="34" charset="-122"/>
                 <a:cs typeface="Calibri" pitchFamily="34" charset="-120"/>
               </a:rPr>
-              <a:t>4 TOML files with detailed instructions, model routing, sandbox modes. Each agent runs in its own Codex sandbox — no custom execution code.</a:t>
+              <a:t>4 TOML files with detailed instructions, model routing (gpt-5.3-codex), sandbox modes. Each agent runs in its own Codex sandbox — no custom execution code.</a:t>
             </a:r>
             <a:endParaRPr lang="en-US" sz="1000" dirty="0"/>
           </a:p>
@@ -12523,7 +12523,7 @@
                 <a:ea typeface="Trebuchet MS" pitchFamily="34" charset="-122"/>
                 <a:cs typeface="Trebuchet MS" pitchFamily="34" charset="-120"/>
               </a:rPr>
-              <a:t>Orchestrator API (888 lines)</a:t>
+              <a:t>Thin Orchestrator API</a:t>
             </a:r>
             <a:endParaRPr lang="en-US" sz="1300" dirty="0"/>
           </a:p>
@@ -12828,7 +12828,7 @@
                 <a:ea typeface="Calibri" pitchFamily="34" charset="-122"/>
                 <a:cs typeface="Calibri" pitchFamily="34" charset="-120"/>
               </a:rPr>
-              <a:t>Python-based agent framework with custom context engine, tools, and persistence</a:t>
+              <a:t>Python SDK for MS Agents with custom context engine, tools, and persistence</a:t>
             </a:r>
             <a:endParaRPr lang="en-US" sz="1300" dirty="0"/>
           </a:p>
@@ -12953,7 +12953,7 @@
                 <a:ea typeface="Calibri" pitchFamily="34" charset="-122"/>
                 <a:cs typeface="Calibri" pitchFamily="34" charset="-120"/>
               </a:rPr>
-              <a:t>MS Agent Framework  |  @tool Decorator  |  FoundryChatClient  |  Speed Profiles</a:t>
+              <a:t>Python SDK for MS Agents  |  @tool Decorator  |  FoundryChatClient  |  Speed Profiles</a:t>
             </a:r>
             <a:endParaRPr lang="en-US" sz="1300" dirty="0"/>
           </a:p>
@@ -13044,7 +13044,7 @@
                 <a:ea typeface="Calibri" pitchFamily="34" charset="-122"/>
                 <a:cs typeface="Calibri" pitchFamily="34" charset="-120"/>
               </a:rPr>
-              <a:t>99 lines Python</a:t>
+              <a:t>Custom Python</a:t>
             </a:r>
             <a:endParaRPr lang="en-US" sz="900" dirty="0"/>
           </a:p>
@@ -13279,7 +13279,7 @@
                 <a:ea typeface="Calibri" pitchFamily="34" charset="-122"/>
                 <a:cs typeface="Calibri" pitchFamily="34" charset="-120"/>
               </a:rPr>
-              <a:t>184 lines Python</a:t>
+              <a:t>Custom Python</a:t>
             </a:r>
             <a:endParaRPr lang="en-US" sz="900" dirty="0"/>
           </a:p>
@@ -13514,7 +13514,7 @@
                 <a:ea typeface="Calibri" pitchFamily="34" charset="-122"/>
                 <a:cs typeface="Calibri" pitchFamily="34" charset="-120"/>
               </a:rPr>
-              <a:t>239 lines Python</a:t>
+              <a:t>Custom Python</a:t>
             </a:r>
             <a:endParaRPr lang="en-US" sz="900" dirty="0"/>
           </a:p>
@@ -13749,7 +13749,7 @@
                 <a:ea typeface="Calibri" pitchFamily="34" charset="-122"/>
                 <a:cs typeface="Calibri" pitchFamily="34" charset="-120"/>
               </a:rPr>
-              <a:t>173 lines Python</a:t>
+              <a:t>Custom Python</a:t>
             </a:r>
             <a:endParaRPr lang="en-US" sz="900" dirty="0"/>
           </a:p>
@@ -13952,7 +13952,7 @@
                 <a:ea typeface="Calibri" pitchFamily="34" charset="-122"/>
                 <a:cs typeface="Calibri" pitchFamily="34" charset="-120"/>
               </a:rPr>
-              <a:t>Total: 2,394 lines Python  |  SQLite persistence  |  Custom context engine (419 lines)  |  Custom tools (385 lines)</a:t>
+              <a:t>Effort: High (all custom Python)  |  SQLite persistence  |  Custom context engine  |  Custom tools</a:t>
             </a:r>
             <a:endParaRPr lang="en-US" sz="1000" dirty="0"/>
           </a:p>
@@ -14134,7 +14134,7 @@
                 <a:ea typeface="Trebuchet MS" pitchFamily="34" charset="-122"/>
                 <a:cs typeface="Trebuchet MS" pitchFamily="34" charset="-120"/>
               </a:rPr>
-              <a:t>Custom Context Engine (419 lines)</a:t>
+              <a:t>Custom Context Engine</a:t>
             </a:r>
             <a:endParaRPr lang="en-US" sz="1300" dirty="0"/>
           </a:p>
@@ -14176,7 +14176,7 @@
                 <a:ea typeface="Calibri" pitchFamily="34" charset="-122"/>
                 <a:cs typeface="Calibri" pitchFamily="34" charset="-120"/>
               </a:rPr>
-              <a:t>Semantic chunker splits at AST boundaries (131 lines). Token estimator with complexity multipliers (56 lines). Progressive compressor: 30% older history (108 lines). Complexity scorer: 12 weighted patterns (124 lines).</a:t>
+              <a:t>Semantic chunker splits at AST boundaries. Token estimator with complexity multipliers. Progressive compressor: 30% older history. Complexity scorer: 12 weighted patterns. Effort: High.</a:t>
             </a:r>
             <a:endParaRPr lang="en-US" sz="1000" dirty="0"/>
           </a:p>
@@ -14267,7 +14267,7 @@
                 <a:ea typeface="Trebuchet MS" pitchFamily="34" charset="-122"/>
                 <a:cs typeface="Trebuchet MS" pitchFamily="34" charset="-120"/>
               </a:rPr>
-              <a:t>Custom Agent Tools (385 lines)</a:t>
+              <a:t>Custom Agent Tools</a:t>
             </a:r>
             <a:endParaRPr lang="en-US" sz="1300" dirty="0"/>
           </a:p>
@@ -14309,7 +14309,7 @@
                 <a:ea typeface="Calibri" pitchFamily="34" charset="-122"/>
                 <a:cs typeface="Calibri" pitchFamily="34" charset="-120"/>
               </a:rPr>
-              <a:t>file_tools.py: read, write, search, list (104 lines). ast_tools.py: regex-based import/function parsing (147 lines). test_runner.py: pytest/jest subprocess + coverage (134 lines). All @tool decorated.</a:t>
+              <a:t>file_tools.py: read, write, search, list. ast_tools.py: regex-based import/function parsing. test_runner.py: pytest/jest subprocess + coverage. All @tool decorated via Python SDK.</a:t>
             </a:r>
             <a:endParaRPr lang="en-US" sz="1000" dirty="0"/>
           </a:p>
@@ -14533,7 +14533,7 @@
                 <a:ea typeface="Trebuchet MS" pitchFamily="34" charset="-122"/>
                 <a:cs typeface="Trebuchet MS" pitchFamily="34" charset="-120"/>
               </a:rPr>
-              <a:t>Pipeline Orchestrator (248 lines)</a:t>
+              <a:t>Pipeline Orchestrator</a:t>
             </a:r>
             <a:endParaRPr lang="en-US" sz="1300" dirty="0"/>
           </a:p>
@@ -14575,7 +14575,7 @@
                 <a:ea typeface="Calibri" pitchFamily="34" charset="-122"/>
                 <a:cs typeface="Calibri" pitchFamily="34" charset="-120"/>
               </a:rPr>
-              <a:t>Sequential 6-gate flow in pipeline.py. Self-healing loop (max 3 attempts). Sprint contract negotiation. State updates + coverage ratchet enforcement. All hand-coded in Python.</a:t>
+              <a:t>Sequential 6-gate flow in pipeline.py. Self-healing loop (max 3 attempts). Sprint contract negotiation. State updates + coverage ratchet enforcement. All hand-coded in Python. Effort: High.</a:t>
             </a:r>
             <a:endParaRPr lang="en-US" sz="1000" dirty="0"/>
           </a:p>
@@ -14666,7 +14666,7 @@
                 <a:ea typeface="Trebuchet MS" pitchFamily="34" charset="-122"/>
                 <a:cs typeface="Trebuchet MS" pitchFamily="34" charset="-120"/>
               </a:rPr>
-              <a:t>SQLite Persistence (326 lines)</a:t>
+              <a:t>SQLite Persistence</a:t>
             </a:r>
             <a:endParaRPr lang="en-US" sz="1300" dirty="0"/>
           </a:p>
@@ -14708,7 +14708,7 @@
                 <a:ea typeface="Calibri" pitchFamily="34" charset="-122"/>
                 <a:cs typeface="Calibri" pitchFamily="34" charset="-120"/>
               </a:rPr>
-              <a:t>4 tables: migration_runs, analysis_cache, chunk_status, dependencies. Checkpoint/resume: find last completed chunk. Optional Azure Blob sync for cloud scaling.</a:t>
+              <a:t>4 tables: migration_runs, analysis_cache, chunk_status, dependencies. Checkpoint/resume: find last completed chunk. Optional Azure Blob sync for cloud scaling. Effort: Medium.</a:t>
             </a:r>
             <a:endParaRPr lang="en-US" sz="1000" dirty="0"/>
           </a:p>
@@ -14841,7 +14841,7 @@
                 <a:ea typeface="Calibri" pitchFamily="34" charset="-122"/>
                 <a:cs typeface="Calibri" pitchFamily="34" charset="-120"/>
               </a:rPr>
-              <a:t>No sandboxing (shared process). No built-in tools (custom file/AST/test tools). No auto-compaction (custom compressor). No agent isolation (shared context). 32 pip dependencies.</a:t>
+              <a:t>No sandboxing (shared process). No built-in tools (custom file/AST/test tools). No auto-compaction (custom compressor). No agent isolation (shared context). Effort: High overall.</a:t>
             </a:r>
             <a:endParaRPr lang="en-US" sz="1000" dirty="0"/>
           </a:p>
@@ -15189,7 +15189,75 @@
                           <a:ea typeface="Calibri" pitchFamily="34" charset="-122"/>
                           <a:cs typeface="Calibri" pitchFamily="34" charset="-120"/>
                         </a:rPr>
-                        <a:t>Total Codebase</a:t>
+                        <a:t>Custom Code Effort</a:t>
+                      </a:r>
+                      <a:endParaRPr lang="en-US" sz="1000" dirty="0">
+                        <a:latin typeface="Calibri" charset="0"/>
+                        <a:ea typeface="Calibri" charset="0"/>
+                        <a:cs typeface="Calibri" charset="0"/>
+                      </a:endParaRPr>
+                    </a:p>
+                  </a:txBody>
+                  <a:tcPr marL="91440" marR="91440" marT="45720" marB="45720">
+                    <a:lnL w="6350" cap="flat" cmpd="sng" algn="ctr">
+                      <a:solidFill>
+                        <a:srgbClr val="CBD5E1"/>
+                      </a:solidFill>
+                      <a:prstDash val="solid"/>
+                      <a:round/>
+                      <a:headEnd type="none" w="med" len="med"/>
+                      <a:tailEnd type="none" w="med" len="med"/>
+                    </a:lnL>
+                    <a:lnR w="6350" cap="flat" cmpd="sng" algn="ctr">
+                      <a:solidFill>
+                        <a:srgbClr val="CBD5E1"/>
+                      </a:solidFill>
+                      <a:prstDash val="solid"/>
+                      <a:round/>
+                      <a:headEnd type="none" w="med" len="med"/>
+                      <a:tailEnd type="none" w="med" len="med"/>
+                    </a:lnR>
+                    <a:lnT w="6350" cap="flat" cmpd="sng" algn="ctr">
+                      <a:solidFill>
+                        <a:srgbClr val="CBD5E1"/>
+                      </a:solidFill>
+                      <a:prstDash val="solid"/>
+                      <a:round/>
+                      <a:headEnd type="none" w="med" len="med"/>
+                      <a:tailEnd type="none" w="med" len="med"/>
+                    </a:lnT>
+                    <a:lnB w="6350" cap="flat" cmpd="sng" algn="ctr">
+                      <a:solidFill>
+                        <a:srgbClr val="CBD5E1"/>
+                      </a:solidFill>
+                      <a:prstDash val="solid"/>
+                      <a:round/>
+                      <a:headEnd type="none" w="med" len="med"/>
+                      <a:tailEnd type="none" w="med" len="med"/>
+                    </a:lnB>
+                    <a:solidFill>
+                      <a:srgbClr val="FFFFFF"/>
+                    </a:solidFill>
+                  </a:tcPr>
+                </a:tc>
+                <a:tc>
+                  <a:txBody>
+                    <a:bodyPr/>
+                    <a:lstStyle/>
+                    <a:p>
+                      <a:pPr algn="ctr" indent="0" marL="0">
+                        <a:buNone/>
+                      </a:pPr>
+                      <a:r>
+                        <a:rPr lang="en-US" sz="1000" dirty="0">
+                          <a:solidFill>
+                            <a:srgbClr val="059669"/>
+                          </a:solidFill>
+                          <a:latin typeface="Calibri" pitchFamily="34" charset="0"/>
+                          <a:ea typeface="Calibri" pitchFamily="34" charset="-122"/>
+                          <a:cs typeface="Calibri" pitchFamily="34" charset="-120"/>
+                        </a:rPr>
+                        <a:t>Low (mostly config)</a:t>
                       </a:r>
                       <a:endParaRPr lang="en-US" sz="1000" dirty="0">
                         <a:latin typeface="Calibri" charset="0"/>
@@ -15257,281 +15325,7 @@
                           <a:ea typeface="Calibri" pitchFamily="34" charset="-122"/>
                           <a:cs typeface="Calibri" pitchFamily="34" charset="-120"/>
                         </a:rPr>
-                        <a:t>3,757 lines (36% config)</a:t>
-                      </a:r>
-                      <a:endParaRPr lang="en-US" sz="1000" dirty="0">
-                        <a:latin typeface="Calibri" charset="0"/>
-                        <a:ea typeface="Calibri" charset="0"/>
-                        <a:cs typeface="Calibri" charset="0"/>
-                      </a:endParaRPr>
-                    </a:p>
-                  </a:txBody>
-                  <a:tcPr marL="91440" marR="91440" marT="45720" marB="45720">
-                    <a:lnL w="6350" cap="flat" cmpd="sng" algn="ctr">
-                      <a:solidFill>
-                        <a:srgbClr val="CBD5E1"/>
-                      </a:solidFill>
-                      <a:prstDash val="solid"/>
-                      <a:round/>
-                      <a:headEnd type="none" w="med" len="med"/>
-                      <a:tailEnd type="none" w="med" len="med"/>
-                    </a:lnL>
-                    <a:lnR w="6350" cap="flat" cmpd="sng" algn="ctr">
-                      <a:solidFill>
-                        <a:srgbClr val="CBD5E1"/>
-                      </a:solidFill>
-                      <a:prstDash val="solid"/>
-                      <a:round/>
-                      <a:headEnd type="none" w="med" len="med"/>
-                      <a:tailEnd type="none" w="med" len="med"/>
-                    </a:lnR>
-                    <a:lnT w="6350" cap="flat" cmpd="sng" algn="ctr">
-                      <a:solidFill>
-                        <a:srgbClr val="CBD5E1"/>
-                      </a:solidFill>
-                      <a:prstDash val="solid"/>
-                      <a:round/>
-                      <a:headEnd type="none" w="med" len="med"/>
-                      <a:tailEnd type="none" w="med" len="med"/>
-                    </a:lnT>
-                    <a:lnB w="6350" cap="flat" cmpd="sng" algn="ctr">
-                      <a:solidFill>
-                        <a:srgbClr val="CBD5E1"/>
-                      </a:solidFill>
-                      <a:prstDash val="solid"/>
-                      <a:round/>
-                      <a:headEnd type="none" w="med" len="med"/>
-                      <a:tailEnd type="none" w="med" len="med"/>
-                    </a:lnB>
-                    <a:solidFill>
-                      <a:srgbClr val="FFFFFF"/>
-                    </a:solidFill>
-                  </a:tcPr>
-                </a:tc>
-                <a:tc>
-                  <a:txBody>
-                    <a:bodyPr/>
-                    <a:lstStyle/>
-                    <a:p>
-                      <a:pPr algn="ctr" indent="0" marL="0">
-                        <a:buNone/>
-                      </a:pPr>
-                      <a:r>
-                        <a:rPr lang="en-US" sz="1000" dirty="0">
-                          <a:solidFill>
-                            <a:srgbClr val="475569"/>
-                          </a:solidFill>
-                          <a:latin typeface="Calibri" pitchFamily="34" charset="0"/>
-                          <a:ea typeface="Calibri" pitchFamily="34" charset="-122"/>
-                          <a:cs typeface="Calibri" pitchFamily="34" charset="-120"/>
-                        </a:rPr>
-                        <a:t>3,513 lines (all Python)</a:t>
-                      </a:r>
-                      <a:endParaRPr lang="en-US" sz="1000" dirty="0">
-                        <a:latin typeface="Calibri" charset="0"/>
-                        <a:ea typeface="Calibri" charset="0"/>
-                        <a:cs typeface="Calibri" charset="0"/>
-                      </a:endParaRPr>
-                    </a:p>
-                  </a:txBody>
-                  <a:tcPr marL="91440" marR="91440" marT="45720" marB="45720">
-                    <a:lnL w="6350" cap="flat" cmpd="sng" algn="ctr">
-                      <a:solidFill>
-                        <a:srgbClr val="CBD5E1"/>
-                      </a:solidFill>
-                      <a:prstDash val="solid"/>
-                      <a:round/>
-                      <a:headEnd type="none" w="med" len="med"/>
-                      <a:tailEnd type="none" w="med" len="med"/>
-                    </a:lnL>
-                    <a:lnR w="6350" cap="flat" cmpd="sng" algn="ctr">
-                      <a:solidFill>
-                        <a:srgbClr val="CBD5E1"/>
-                      </a:solidFill>
-                      <a:prstDash val="solid"/>
-                      <a:round/>
-                      <a:headEnd type="none" w="med" len="med"/>
-                      <a:tailEnd type="none" w="med" len="med"/>
-                    </a:lnR>
-                    <a:lnT w="6350" cap="flat" cmpd="sng" algn="ctr">
-                      <a:solidFill>
-                        <a:srgbClr val="CBD5E1"/>
-                      </a:solidFill>
-                      <a:prstDash val="solid"/>
-                      <a:round/>
-                      <a:headEnd type="none" w="med" len="med"/>
-                      <a:tailEnd type="none" w="med" len="med"/>
-                    </a:lnT>
-                    <a:lnB w="6350" cap="flat" cmpd="sng" algn="ctr">
-                      <a:solidFill>
-                        <a:srgbClr val="CBD5E1"/>
-                      </a:solidFill>
-                      <a:prstDash val="solid"/>
-                      <a:round/>
-                      <a:headEnd type="none" w="med" len="med"/>
-                      <a:tailEnd type="none" w="med" len="med"/>
-                    </a:lnB>
-                    <a:solidFill>
-                      <a:srgbClr val="FFFFFF"/>
-                    </a:solidFill>
-                  </a:tcPr>
-                </a:tc>
-              </a:tr>
-              <a:tr h="292608">
-                <a:tc>
-                  <a:txBody>
-                    <a:bodyPr/>
-                    <a:lstStyle/>
-                    <a:p>
-                      <a:pPr algn="l" indent="0" marL="0">
-                        <a:buNone/>
-                      </a:pPr>
-                      <a:r>
-                        <a:rPr lang="en-US" sz="1000" b="1" dirty="0">
-                          <a:solidFill>
-                            <a:srgbClr val="0F172A"/>
-                          </a:solidFill>
-                          <a:latin typeface="Calibri" pitchFamily="34" charset="0"/>
-                          <a:ea typeface="Calibri" pitchFamily="34" charset="-122"/>
-                          <a:cs typeface="Calibri" pitchFamily="34" charset="-120"/>
-                        </a:rPr>
-                        <a:t>Custom Code (excl. config)</a:t>
-                      </a:r>
-                      <a:endParaRPr lang="en-US" sz="1000" dirty="0">
-                        <a:latin typeface="Calibri" charset="0"/>
-                        <a:ea typeface="Calibri" charset="0"/>
-                        <a:cs typeface="Calibri" charset="0"/>
-                      </a:endParaRPr>
-                    </a:p>
-                  </a:txBody>
-                  <a:tcPr marL="91440" marR="91440" marT="45720" marB="45720">
-                    <a:lnL w="6350" cap="flat" cmpd="sng" algn="ctr">
-                      <a:solidFill>
-                        <a:srgbClr val="CBD5E1"/>
-                      </a:solidFill>
-                      <a:prstDash val="solid"/>
-                      <a:round/>
-                      <a:headEnd type="none" w="med" len="med"/>
-                      <a:tailEnd type="none" w="med" len="med"/>
-                    </a:lnL>
-                    <a:lnR w="6350" cap="flat" cmpd="sng" algn="ctr">
-                      <a:solidFill>
-                        <a:srgbClr val="CBD5E1"/>
-                      </a:solidFill>
-                      <a:prstDash val="solid"/>
-                      <a:round/>
-                      <a:headEnd type="none" w="med" len="med"/>
-                      <a:tailEnd type="none" w="med" len="med"/>
-                    </a:lnR>
-                    <a:lnT w="6350" cap="flat" cmpd="sng" algn="ctr">
-                      <a:solidFill>
-                        <a:srgbClr val="CBD5E1"/>
-                      </a:solidFill>
-                      <a:prstDash val="solid"/>
-                      <a:round/>
-                      <a:headEnd type="none" w="med" len="med"/>
-                      <a:tailEnd type="none" w="med" len="med"/>
-                    </a:lnT>
-                    <a:lnB w="6350" cap="flat" cmpd="sng" algn="ctr">
-                      <a:solidFill>
-                        <a:srgbClr val="CBD5E1"/>
-                      </a:solidFill>
-                      <a:prstDash val="solid"/>
-                      <a:round/>
-                      <a:headEnd type="none" w="med" len="med"/>
-                      <a:tailEnd type="none" w="med" len="med"/>
-                    </a:lnB>
-                    <a:solidFill>
-                      <a:srgbClr val="FFFFFF"/>
-                    </a:solidFill>
-                  </a:tcPr>
-                </a:tc>
-                <a:tc>
-                  <a:txBody>
-                    <a:bodyPr/>
-                    <a:lstStyle/>
-                    <a:p>
-                      <a:pPr algn="ctr" indent="0" marL="0">
-                        <a:buNone/>
-                      </a:pPr>
-                      <a:r>
-                        <a:rPr lang="en-US" sz="1000" dirty="0">
-                          <a:solidFill>
-                            <a:srgbClr val="059669"/>
-                          </a:solidFill>
-                          <a:latin typeface="Calibri" pitchFamily="34" charset="0"/>
-                          <a:ea typeface="Calibri" pitchFamily="34" charset="-122"/>
-                          <a:cs typeface="Calibri" pitchFamily="34" charset="-120"/>
-                        </a:rPr>
-                        <a:t>888 lines Python + 504 bash</a:t>
-                      </a:r>
-                      <a:endParaRPr lang="en-US" sz="1000" dirty="0">
-                        <a:latin typeface="Calibri" charset="0"/>
-                        <a:ea typeface="Calibri" charset="0"/>
-                        <a:cs typeface="Calibri" charset="0"/>
-                      </a:endParaRPr>
-                    </a:p>
-                  </a:txBody>
-                  <a:tcPr marL="91440" marR="91440" marT="45720" marB="45720">
-                    <a:lnL w="6350" cap="flat" cmpd="sng" algn="ctr">
-                      <a:solidFill>
-                        <a:srgbClr val="CBD5E1"/>
-                      </a:solidFill>
-                      <a:prstDash val="solid"/>
-                      <a:round/>
-                      <a:headEnd type="none" w="med" len="med"/>
-                      <a:tailEnd type="none" w="med" len="med"/>
-                    </a:lnL>
-                    <a:lnR w="6350" cap="flat" cmpd="sng" algn="ctr">
-                      <a:solidFill>
-                        <a:srgbClr val="CBD5E1"/>
-                      </a:solidFill>
-                      <a:prstDash val="solid"/>
-                      <a:round/>
-                      <a:headEnd type="none" w="med" len="med"/>
-                      <a:tailEnd type="none" w="med" len="med"/>
-                    </a:lnR>
-                    <a:lnT w="6350" cap="flat" cmpd="sng" algn="ctr">
-                      <a:solidFill>
-                        <a:srgbClr val="CBD5E1"/>
-                      </a:solidFill>
-                      <a:prstDash val="solid"/>
-                      <a:round/>
-                      <a:headEnd type="none" w="med" len="med"/>
-                      <a:tailEnd type="none" w="med" len="med"/>
-                    </a:lnT>
-                    <a:lnB w="6350" cap="flat" cmpd="sng" algn="ctr">
-                      <a:solidFill>
-                        <a:srgbClr val="CBD5E1"/>
-                      </a:solidFill>
-                      <a:prstDash val="solid"/>
-                      <a:round/>
-                      <a:headEnd type="none" w="med" len="med"/>
-                      <a:tailEnd type="none" w="med" len="med"/>
-                    </a:lnB>
-                    <a:solidFill>
-                      <a:srgbClr val="FFFFFF"/>
-                    </a:solidFill>
-                  </a:tcPr>
-                </a:tc>
-                <a:tc>
-                  <a:txBody>
-                    <a:bodyPr/>
-                    <a:lstStyle/>
-                    <a:p>
-                      <a:pPr algn="ctr" indent="0" marL="0">
-                        <a:buNone/>
-                      </a:pPr>
-                      <a:r>
-                        <a:rPr lang="en-US" sz="1000" dirty="0">
-                          <a:solidFill>
-                            <a:srgbClr val="475569"/>
-                          </a:solidFill>
-                          <a:latin typeface="Calibri" pitchFamily="34" charset="0"/>
-                          <a:ea typeface="Calibri" pitchFamily="34" charset="-122"/>
-                          <a:cs typeface="Calibri" pitchFamily="34" charset="-120"/>
-                        </a:rPr>
-                        <a:t>2,394 lines Python</a:t>
+                        <a:t>High (all custom Python)</a:t>
                       </a:r>
                       <a:endParaRPr lang="en-US" sz="1000" dirty="0">
                         <a:latin typeface="Calibri" charset="0"/>
@@ -15669,7 +15463,7 @@
                           <a:ea typeface="Calibri" pitchFamily="34" charset="-122"/>
                           <a:cs typeface="Calibri" pitchFamily="34" charset="-120"/>
                         </a:rPr>
-                        <a:t>525 lines TOML (declarative)</a:t>
+                        <a:t>Low — TOML (declarative)</a:t>
                       </a:r>
                       <a:endParaRPr lang="en-US" sz="1000" dirty="0">
                         <a:latin typeface="Calibri" charset="0"/>
@@ -15737,7 +15531,7 @@
                           <a:ea typeface="Calibri" pitchFamily="34" charset="-122"/>
                           <a:cs typeface="Calibri" pitchFamily="34" charset="-120"/>
                         </a:rPr>
-                        <a:t>695 lines Python (imperative)</a:t>
+                        <a:t>High — Python (imperative)</a:t>
                       </a:r>
                       <a:endParaRPr lang="en-US" sz="1000" dirty="0">
                         <a:latin typeface="Calibri" charset="0"/>
@@ -15943,7 +15737,7 @@
                           <a:ea typeface="Calibri" pitchFamily="34" charset="-122"/>
                           <a:cs typeface="Calibri" pitchFamily="34" charset="-120"/>
                         </a:rPr>
-                        <a:t>419 lines (4 custom modules)</a:t>
+                        <a:t>High (4 custom modules)</a:t>
                       </a:r>
                       <a:endParaRPr lang="en-US" sz="1000" dirty="0">
                         <a:latin typeface="Calibri" charset="0"/>
@@ -16149,7 +15943,7 @@
                           <a:ea typeface="Calibri" pitchFamily="34" charset="-122"/>
                           <a:cs typeface="Calibri" pitchFamily="34" charset="-120"/>
                         </a:rPr>
-                        <a:t>385 lines (3 custom modules)</a:t>
+                        <a:t>High (3 custom modules)</a:t>
                       </a:r>
                       <a:endParaRPr lang="en-US" sz="1000" dirty="0">
                         <a:latin typeface="Calibri" charset="0"/>
@@ -16287,7 +16081,7 @@
                           <a:ea typeface="Calibri" pitchFamily="34" charset="-122"/>
                           <a:cs typeface="Calibri" pitchFamily="34" charset="-120"/>
                         </a:rPr>
-                        <a:t>Blob Storage (192 lines)</a:t>
+                        <a:t>Low — Blob Storage</a:t>
                       </a:r>
                       <a:endParaRPr lang="en-US" sz="1000" dirty="0">
                         <a:latin typeface="Calibri" charset="0"/>
@@ -16355,7 +16149,7 @@
                           <a:ea typeface="Calibri" pitchFamily="34" charset="-122"/>
                           <a:cs typeface="Calibri" pitchFamily="34" charset="-120"/>
                         </a:rPr>
-                        <a:t>SQLite 4-table (326 lines)</a:t>
+                        <a:t>Medium — SQLite 4-table</a:t>
                       </a:r>
                       <a:endParaRPr lang="en-US" sz="1000" dirty="0">
                         <a:latin typeface="Calibri" charset="0"/>
@@ -16767,7 +16561,7 @@
                           <a:ea typeface="Calibri" pitchFamily="34" charset="-122"/>
                           <a:cs typeface="Calibri" pitchFamily="34" charset="-120"/>
                         </a:rPr>
-                        <a:t>pipeline.py (248 lines custom)</a:t>
+                        <a:t>High — custom pipeline.py</a:t>
                       </a:r>
                       <a:endParaRPr lang="en-US" sz="1000" dirty="0">
                         <a:latin typeface="Calibri" charset="0"/>
@@ -16837,7 +16631,7 @@
                           <a:ea typeface="Calibri" pitchFamily="34" charset="-122"/>
                           <a:cs typeface="Calibri" pitchFamily="34" charset="-120"/>
                         </a:rPr>
-                        <a:t>Test Suite</a:t>
+                        <a:t>Test Suite Effort</a:t>
                       </a:r>
                       <a:endParaRPr lang="en-US" sz="1000" dirty="0">
                         <a:latin typeface="Calibri" charset="0"/>
@@ -16905,7 +16699,7 @@
                           <a:ea typeface="Calibri" pitchFamily="34" charset="-122"/>
                           <a:cs typeface="Calibri" pitchFamily="34" charset="-120"/>
                         </a:rPr>
-                        <a:t>359 lines (4 test modules)</a:t>
+                        <a:t>Low (thin orchestrator only)</a:t>
                       </a:r>
                       <a:endParaRPr lang="en-US" sz="1000" dirty="0">
                         <a:latin typeface="Calibri" charset="0"/>
@@ -16973,7 +16767,7 @@
                           <a:ea typeface="Calibri" pitchFamily="34" charset="-122"/>
                           <a:cs typeface="Calibri" pitchFamily="34" charset="-120"/>
                         </a:rPr>
-                        <a:t>1,119 lines (9 test modules)</a:t>
+                        <a:t>High (agents + tools + context)</a:t>
                       </a:r>
                       <a:endParaRPr lang="en-US" sz="1000" dirty="0">
                         <a:latin typeface="Calibri" charset="0"/>
@@ -17317,7 +17111,7 @@
                           <a:ea typeface="Calibri" pitchFamily="34" charset="-122"/>
                           <a:cs typeface="Calibri" pitchFamily="34" charset="-120"/>
                         </a:rPr>
-                        <a:t>npm: pptxgenjs, Codex CLI</a:t>
+                        <a:t>Codex CLI + thin wrapper</a:t>
                       </a:r>
                       <a:endParaRPr lang="en-US" sz="1000" dirty="0">
                         <a:latin typeface="Calibri" charset="0"/>
@@ -17385,7 +17179,7 @@
                           <a:ea typeface="Calibri" pitchFamily="34" charset="-122"/>
                           <a:cs typeface="Calibri" pitchFamily="34" charset="-120"/>
                         </a:rPr>
-                        <a:t>32 pip packages</a:t>
+                        <a:t>Python SDK + 32 pip packages</a:t>
                       </a:r>
                       <a:endParaRPr lang="en-US" sz="1000" dirty="0">
                         <a:latin typeface="Calibri" charset="0"/>
@@ -17643,6 +17437,212 @@
                   </a:tcPr>
                 </a:tc>
               </a:tr>
+              <a:tr h="292608">
+                <a:tc>
+                  <a:txBody>
+                    <a:bodyPr/>
+                    <a:lstStyle/>
+                    <a:p>
+                      <a:pPr algn="l" indent="0" marL="0">
+                        <a:buNone/>
+                      </a:pPr>
+                      <a:r>
+                        <a:rPr lang="en-US" sz="1000" b="1" dirty="0">
+                          <a:solidFill>
+                            <a:srgbClr val="0F172A"/>
+                          </a:solidFill>
+                          <a:latin typeface="Calibri" pitchFamily="34" charset="0"/>
+                          <a:ea typeface="Calibri" pitchFamily="34" charset="-122"/>
+                          <a:cs typeface="Calibri" pitchFamily="34" charset="-120"/>
+                        </a:rPr>
+                        <a:t>Model</a:t>
+                      </a:r>
+                      <a:endParaRPr lang="en-US" sz="1000" dirty="0">
+                        <a:latin typeface="Calibri" charset="0"/>
+                        <a:ea typeface="Calibri" charset="0"/>
+                        <a:cs typeface="Calibri" charset="0"/>
+                      </a:endParaRPr>
+                    </a:p>
+                  </a:txBody>
+                  <a:tcPr marL="91440" marR="91440" marT="45720" marB="45720">
+                    <a:lnL w="6350" cap="flat" cmpd="sng" algn="ctr">
+                      <a:solidFill>
+                        <a:srgbClr val="CBD5E1"/>
+                      </a:solidFill>
+                      <a:prstDash val="solid"/>
+                      <a:round/>
+                      <a:headEnd type="none" w="med" len="med"/>
+                      <a:tailEnd type="none" w="med" len="med"/>
+                    </a:lnL>
+                    <a:lnR w="6350" cap="flat" cmpd="sng" algn="ctr">
+                      <a:solidFill>
+                        <a:srgbClr val="CBD5E1"/>
+                      </a:solidFill>
+                      <a:prstDash val="solid"/>
+                      <a:round/>
+                      <a:headEnd type="none" w="med" len="med"/>
+                      <a:tailEnd type="none" w="med" len="med"/>
+                    </a:lnR>
+                    <a:lnT w="6350" cap="flat" cmpd="sng" algn="ctr">
+                      <a:solidFill>
+                        <a:srgbClr val="CBD5E1"/>
+                      </a:solidFill>
+                      <a:prstDash val="solid"/>
+                      <a:round/>
+                      <a:headEnd type="none" w="med" len="med"/>
+                      <a:tailEnd type="none" w="med" len="med"/>
+                    </a:lnT>
+                    <a:lnB w="6350" cap="flat" cmpd="sng" algn="ctr">
+                      <a:solidFill>
+                        <a:srgbClr val="CBD5E1"/>
+                      </a:solidFill>
+                      <a:prstDash val="solid"/>
+                      <a:round/>
+                      <a:headEnd type="none" w="med" len="med"/>
+                      <a:tailEnd type="none" w="med" len="med"/>
+                    </a:lnB>
+                    <a:solidFill>
+                      <a:srgbClr val="FFFFFF"/>
+                    </a:solidFill>
+                  </a:tcPr>
+                </a:tc>
+                <a:tc>
+                  <a:txBody>
+                    <a:bodyPr/>
+                    <a:lstStyle/>
+                    <a:p>
+                      <a:pPr algn="ctr" indent="0" marL="0">
+                        <a:buNone/>
+                      </a:pPr>
+                      <a:r>
+                        <a:rPr lang="en-US" sz="1000" dirty="0">
+                          <a:solidFill>
+                            <a:srgbClr val="475569"/>
+                          </a:solidFill>
+                          <a:latin typeface="Calibri" pitchFamily="34" charset="0"/>
+                          <a:ea typeface="Calibri" pitchFamily="34" charset="-122"/>
+                          <a:cs typeface="Calibri" pitchFamily="34" charset="-120"/>
+                        </a:rPr>
+                        <a:t>gpt-5.3-codex (all agents)</a:t>
+                      </a:r>
+                      <a:endParaRPr lang="en-US" sz="1000" dirty="0">
+                        <a:latin typeface="Calibri" charset="0"/>
+                        <a:ea typeface="Calibri" charset="0"/>
+                        <a:cs typeface="Calibri" charset="0"/>
+                      </a:endParaRPr>
+                    </a:p>
+                  </a:txBody>
+                  <a:tcPr marL="91440" marR="91440" marT="45720" marB="45720">
+                    <a:lnL w="6350" cap="flat" cmpd="sng" algn="ctr">
+                      <a:solidFill>
+                        <a:srgbClr val="CBD5E1"/>
+                      </a:solidFill>
+                      <a:prstDash val="solid"/>
+                      <a:round/>
+                      <a:headEnd type="none" w="med" len="med"/>
+                      <a:tailEnd type="none" w="med" len="med"/>
+                    </a:lnL>
+                    <a:lnR w="6350" cap="flat" cmpd="sng" algn="ctr">
+                      <a:solidFill>
+                        <a:srgbClr val="CBD5E1"/>
+                      </a:solidFill>
+                      <a:prstDash val="solid"/>
+                      <a:round/>
+                      <a:headEnd type="none" w="med" len="med"/>
+                      <a:tailEnd type="none" w="med" len="med"/>
+                    </a:lnR>
+                    <a:lnT w="6350" cap="flat" cmpd="sng" algn="ctr">
+                      <a:solidFill>
+                        <a:srgbClr val="CBD5E1"/>
+                      </a:solidFill>
+                      <a:prstDash val="solid"/>
+                      <a:round/>
+                      <a:headEnd type="none" w="med" len="med"/>
+                      <a:tailEnd type="none" w="med" len="med"/>
+                    </a:lnT>
+                    <a:lnB w="6350" cap="flat" cmpd="sng" algn="ctr">
+                      <a:solidFill>
+                        <a:srgbClr val="CBD5E1"/>
+                      </a:solidFill>
+                      <a:prstDash val="solid"/>
+                      <a:round/>
+                      <a:headEnd type="none" w="med" len="med"/>
+                      <a:tailEnd type="none" w="med" len="med"/>
+                    </a:lnB>
+                    <a:solidFill>
+                      <a:srgbClr val="FFFFFF"/>
+                    </a:solidFill>
+                  </a:tcPr>
+                </a:tc>
+                <a:tc>
+                  <a:txBody>
+                    <a:bodyPr/>
+                    <a:lstStyle/>
+                    <a:p>
+                      <a:pPr algn="ctr" indent="0" marL="0">
+                        <a:buNone/>
+                      </a:pPr>
+                      <a:r>
+                        <a:rPr lang="en-US" sz="1000" dirty="0">
+                          <a:solidFill>
+                            <a:srgbClr val="475569"/>
+                          </a:solidFill>
+                          <a:latin typeface="Calibri" pitchFamily="34" charset="0"/>
+                          <a:ea typeface="Calibri" pitchFamily="34" charset="-122"/>
+                          <a:cs typeface="Calibri" pitchFamily="34" charset="-120"/>
+                        </a:rPr>
+                        <a:t>gpt-4o / gpt-4o-mini</a:t>
+                      </a:r>
+                      <a:endParaRPr lang="en-US" sz="1000" dirty="0">
+                        <a:latin typeface="Calibri" charset="0"/>
+                        <a:ea typeface="Calibri" charset="0"/>
+                        <a:cs typeface="Calibri" charset="0"/>
+                      </a:endParaRPr>
+                    </a:p>
+                  </a:txBody>
+                  <a:tcPr marL="91440" marR="91440" marT="45720" marB="45720">
+                    <a:lnL w="6350" cap="flat" cmpd="sng" algn="ctr">
+                      <a:solidFill>
+                        <a:srgbClr val="CBD5E1"/>
+                      </a:solidFill>
+                      <a:prstDash val="solid"/>
+                      <a:round/>
+                      <a:headEnd type="none" w="med" len="med"/>
+                      <a:tailEnd type="none" w="med" len="med"/>
+                    </a:lnL>
+                    <a:lnR w="6350" cap="flat" cmpd="sng" algn="ctr">
+                      <a:solidFill>
+                        <a:srgbClr val="CBD5E1"/>
+                      </a:solidFill>
+                      <a:prstDash val="solid"/>
+                      <a:round/>
+                      <a:headEnd type="none" w="med" len="med"/>
+                      <a:tailEnd type="none" w="med" len="med"/>
+                    </a:lnR>
+                    <a:lnT w="6350" cap="flat" cmpd="sng" algn="ctr">
+                      <a:solidFill>
+                        <a:srgbClr val="CBD5E1"/>
+                      </a:solidFill>
+                      <a:prstDash val="solid"/>
+                      <a:round/>
+                      <a:headEnd type="none" w="med" len="med"/>
+                      <a:tailEnd type="none" w="med" len="med"/>
+                    </a:lnT>
+                    <a:lnB w="6350" cap="flat" cmpd="sng" algn="ctr">
+                      <a:solidFill>
+                        <a:srgbClr val="CBD5E1"/>
+                      </a:solidFill>
+                      <a:prstDash val="solid"/>
+                      <a:round/>
+                      <a:headEnd type="none" w="med" len="med"/>
+                      <a:tailEnd type="none" w="med" len="med"/>
+                    </a:lnB>
+                    <a:solidFill>
+                      <a:srgbClr val="FFFFFF"/>
+                    </a:solidFill>
+                  </a:tcPr>
+                </a:tc>
+              </a:tr>
             </a:tbl>
           </a:graphicData>
         </a:graphic>
@@ -18194,7 +18194,7 @@
                 <a:ea typeface="Calibri" pitchFamily="34" charset="-122"/>
                 <a:cs typeface="Calibri" pitchFamily="34" charset="-120"/>
               </a:rPr>
-              <a:t>Effort: 525 lines TOML config</a:t>
+              <a:t>Effort: Low (config only)</a:t>
             </a:r>
             <a:endParaRPr lang="en-US" sz="850" dirty="0"/>
           </a:p>
@@ -18236,7 +18236,7 @@
                 <a:ea typeface="Calibri" pitchFamily="34" charset="-122"/>
                 <a:cs typeface="Calibri" pitchFamily="34" charset="-120"/>
               </a:rPr>
-              <a:t>TDD-first: coder.py (184 lines)</a:t>
+              <a:t>TDD-first: custom coder agent</a:t>
             </a:r>
             <a:endParaRPr lang="en-US" sz="850" dirty="0"/>
           </a:p>
@@ -18256,7 +18256,7 @@
                 <a:ea typeface="Calibri" pitchFamily="34" charset="-122"/>
                 <a:cs typeface="Calibri" pitchFamily="34" charset="-120"/>
               </a:rPr>
-              <a:t>Ratcheting: state_manager.py</a:t>
+              <a:t>Ratcheting: custom state mgr</a:t>
             </a:r>
             <a:endParaRPr lang="en-US" sz="850" dirty="0"/>
           </a:p>
@@ -18276,7 +18276,7 @@
                 <a:ea typeface="Calibri" pitchFamily="34" charset="-122"/>
                 <a:cs typeface="Calibri" pitchFamily="34" charset="-120"/>
               </a:rPr>
-              <a:t>(116 lines custom logic)</a:t>
+              <a:t>Sprint contracts: custom</a:t>
             </a:r>
             <a:endParaRPr lang="en-US" sz="850" dirty="0"/>
           </a:p>
@@ -18296,7 +18296,7 @@
                 <a:ea typeface="Calibri" pitchFamily="34" charset="-122"/>
                 <a:cs typeface="Calibri" pitchFamily="34" charset="-120"/>
               </a:rPr>
-              <a:t>Sprint contracts: pipeline.py</a:t>
+              <a:t>negotiation in pipeline.py</a:t>
             </a:r>
             <a:endParaRPr lang="en-US" sz="850" dirty="0"/>
           </a:p>
@@ -18316,7 +18316,7 @@
                 <a:ea typeface="Calibri" pitchFamily="34" charset="-122"/>
                 <a:cs typeface="Calibri" pitchFamily="34" charset="-120"/>
               </a:rPr>
-              <a:t>negotiation loop (248 lines)</a:t>
+              <a:t>6-gate flow hand-coded</a:t>
             </a:r>
             <a:endParaRPr lang="en-US" sz="850" dirty="0"/>
           </a:p>
@@ -18336,7 +18336,7 @@
                 <a:ea typeface="Calibri" pitchFamily="34" charset="-122"/>
                 <a:cs typeface="Calibri" pitchFamily="34" charset="-120"/>
               </a:rPr>
-              <a:t>6-gate flow hand-coded</a:t>
+              <a:t>Learned rules: custom I/O</a:t>
             </a:r>
             <a:endParaRPr lang="en-US" sz="850" dirty="0"/>
           </a:p>
@@ -18347,17 +18347,6 @@
               </a:lnSpc>
               <a:buNone/>
             </a:pPr>
-            <a:r>
-              <a:rPr lang="en-US" sz="850" dirty="0">
-                <a:solidFill>
-                  <a:srgbClr val="334155"/>
-                </a:solidFill>
-                <a:latin typeface="Calibri" pitchFamily="34" charset="0"/>
-                <a:ea typeface="Calibri" pitchFamily="34" charset="-122"/>
-                <a:cs typeface="Calibri" pitchFamily="34" charset="-120"/>
-              </a:rPr>
-              <a:t>Learned rules: custom I/O</a:t>
-            </a:r>
             <a:endParaRPr lang="en-US" sz="850" dirty="0"/>
           </a:p>
           <a:p>
@@ -18367,15 +18356,6 @@
               </a:lnSpc>
               <a:buNone/>
             </a:pPr>
-            <a:endParaRPr lang="en-US" sz="850" dirty="0"/>
-          </a:p>
-          <a:p>
-            <a:pPr indent="0" marL="0">
-              <a:lnSpc>
-                <a:spcPct val="130000"/>
-              </a:lnSpc>
-              <a:buNone/>
-            </a:pPr>
             <a:r>
               <a:rPr lang="en-US" sz="850" dirty="0">
                 <a:solidFill>
@@ -18385,7 +18365,7 @@
                 <a:ea typeface="Calibri" pitchFamily="34" charset="-122"/>
                 <a:cs typeface="Calibri" pitchFamily="34" charset="-120"/>
               </a:rPr>
-              <a:t>Effort: 695 lines Python code</a:t>
+              <a:t>Effort: High (all custom Python)</a:t>
             </a:r>
             <a:endParaRPr lang="en-US" sz="850" dirty="0"/>
           </a:p>
@@ -18847,7 +18827,7 @@
                 <a:ea typeface="Calibri" pitchFamily="34" charset="-122"/>
                 <a:cs typeface="Calibri" pitchFamily="34" charset="-120"/>
               </a:rPr>
-              <a:t>Effort: Zero custom code</a:t>
+              <a:t>Effort: Zero (platform built-in)</a:t>
             </a:r>
             <a:endParaRPr lang="en-US" sz="850" dirty="0"/>
           </a:p>
@@ -18889,7 +18869,7 @@
                 <a:ea typeface="Calibri" pitchFamily="34" charset="-122"/>
                 <a:cs typeface="Calibri" pitchFamily="34" charset="-120"/>
               </a:rPr>
-              <a:t>chunker.py: 131 lines (AST split)</a:t>
+              <a:t>Custom semantic chunker</a:t>
             </a:r>
             <a:endParaRPr lang="en-US" sz="850" dirty="0"/>
           </a:p>
@@ -18909,7 +18889,7 @@
                 <a:ea typeface="Calibri" pitchFamily="34" charset="-122"/>
                 <a:cs typeface="Calibri" pitchFamily="34" charset="-120"/>
               </a:rPr>
-              <a:t>token_estimator.py: 56 lines</a:t>
+              <a:t>Custom token estimator</a:t>
             </a:r>
             <a:endParaRPr lang="en-US" sz="850" dirty="0"/>
           </a:p>
@@ -18929,7 +18909,7 @@
                 <a:ea typeface="Calibri" pitchFamily="34" charset="-122"/>
                 <a:cs typeface="Calibri" pitchFamily="34" charset="-120"/>
               </a:rPr>
-              <a:t>compressor.py: 108 lines</a:t>
+              <a:t>Custom progressive compressor</a:t>
             </a:r>
             <a:endParaRPr lang="en-US" sz="850" dirty="0"/>
           </a:p>
@@ -18949,7 +18929,7 @@
                 <a:ea typeface="Calibri" pitchFamily="34" charset="-122"/>
                 <a:cs typeface="Calibri" pitchFamily="34" charset="-120"/>
               </a:rPr>
-              <a:t>(30% progressive compression)</a:t>
+              <a:t>(30% older history reduction)</a:t>
             </a:r>
             <a:endParaRPr lang="en-US" sz="850" dirty="0"/>
           </a:p>
@@ -18969,7 +18949,7 @@
                 <a:ea typeface="Calibri" pitchFamily="34" charset="-122"/>
                 <a:cs typeface="Calibri" pitchFamily="34" charset="-120"/>
               </a:rPr>
-              <a:t>complexity_scorer.py: 124 lines</a:t>
+              <a:t>Custom complexity scorer</a:t>
             </a:r>
             <a:endParaRPr lang="en-US" sz="850" dirty="0"/>
           </a:p>
@@ -19038,7 +19018,7 @@
                 <a:ea typeface="Calibri" pitchFamily="34" charset="-122"/>
                 <a:cs typeface="Calibri" pitchFamily="34" charset="-120"/>
               </a:rPr>
-              <a:t>Effort: 419 lines Python code</a:t>
+              <a:t>Effort: High (4 custom modules)</a:t>
             </a:r>
             <a:endParaRPr lang="en-US" sz="850" dirty="0"/>
           </a:p>
@@ -19500,7 +19480,7 @@
                 <a:ea typeface="Calibri" pitchFamily="34" charset="-122"/>
                 <a:cs typeface="Calibri" pitchFamily="34" charset="-120"/>
               </a:rPr>
-              <a:t>Effort: 504 lines bash scripts</a:t>
+              <a:t>Effort: Low (config + scripts)</a:t>
             </a:r>
             <a:endParaRPr lang="en-US" sz="850" dirty="0"/>
           </a:p>
@@ -19691,7 +19671,7 @@
                 <a:ea typeface="Calibri" pitchFamily="34" charset="-122"/>
                 <a:cs typeface="Calibri" pitchFamily="34" charset="-120"/>
               </a:rPr>
-              <a:t>Effort: 326 lines persistence</a:t>
+              <a:t>Effort: Medium (config + code)</a:t>
             </a:r>
             <a:endParaRPr lang="en-US" sz="850" dirty="0"/>
           </a:p>
@@ -20004,7 +19984,7 @@
                 <a:ea typeface="Calibri" pitchFamily="34" charset="-122"/>
                 <a:cs typeface="Calibri" pitchFamily="34" charset="-120"/>
               </a:rPr>
-              <a:t>FastAPI: api.py (380 lines)</a:t>
+              <a:t>FastAPI thin orchestrator</a:t>
             </a:r>
             <a:endParaRPr lang="en-US" sz="850" dirty="0"/>
           </a:p>
@@ -20024,7 +20004,7 @@
                 <a:ea typeface="Calibri" pitchFamily="34" charset="-122"/>
                 <a:cs typeface="Calibri" pitchFamily="34" charset="-120"/>
               </a:rPr>
-              <a:t>Codex CLI wrapper (141 lines)</a:t>
+              <a:t>Codex CLI subprocess wrapper</a:t>
             </a:r>
             <a:endParaRPr lang="en-US" sz="850" dirty="0"/>
           </a:p>
@@ -20044,7 +20024,7 @@
                 <a:ea typeface="Calibri" pitchFamily="34" charset="-122"/>
                 <a:cs typeface="Calibri" pitchFamily="34" charset="-120"/>
               </a:rPr>
-              <a:t>ADO client: ado_client.py</a:t>
+              <a:t>ADO client for PR creation</a:t>
             </a:r>
             <a:endParaRPr lang="en-US" sz="850" dirty="0"/>
           </a:p>
@@ -20064,7 +20044,7 @@
                 <a:ea typeface="Calibri" pitchFamily="34" charset="-122"/>
                 <a:cs typeface="Calibri" pitchFamily="34" charset="-120"/>
               </a:rPr>
-              <a:t>(175 lines — PR + WI update)</a:t>
+              <a:t>and work item updates</a:t>
             </a:r>
             <a:endParaRPr lang="en-US" sz="850" dirty="0"/>
           </a:p>
@@ -20084,7 +20064,7 @@
                 <a:ea typeface="Calibri" pitchFamily="34" charset="-122"/>
                 <a:cs typeface="Calibri" pitchFamily="34" charset="-120"/>
               </a:rPr>
-              <a:t>Blob state sync (192 lines)</a:t>
+              <a:t>Blob state sync for persistence</a:t>
             </a:r>
             <a:endParaRPr lang="en-US" sz="850" dirty="0"/>
           </a:p>
@@ -20153,7 +20133,7 @@
                 <a:ea typeface="Calibri" pitchFamily="34" charset="-122"/>
                 <a:cs typeface="Calibri" pitchFamily="34" charset="-120"/>
               </a:rPr>
-              <a:t>Effort: 888 lines orchestrator</a:t>
+              <a:t>Effort: Low (thin API wrapper)</a:t>
             </a:r>
             <a:endParaRPr lang="en-US" sz="850" dirty="0"/>
           </a:p>
@@ -20195,7 +20175,7 @@
                 <a:ea typeface="Calibri" pitchFamily="34" charset="-122"/>
                 <a:cs typeface="Calibri" pitchFamily="34" charset="-120"/>
               </a:rPr>
-              <a:t>FastAPI: api.py (180 lines)</a:t>
+              <a:t>FastAPI orchestrator API</a:t>
             </a:r>
             <a:endParaRPr lang="en-US" sz="850" dirty="0"/>
           </a:p>
@@ -20215,7 +20195,7 @@
                 <a:ea typeface="Calibri" pitchFamily="34" charset="-122"/>
                 <a:cs typeface="Calibri" pitchFamily="34" charset="-120"/>
               </a:rPr>
-              <a:t>Pipeline: pipeline.py (248 lines)</a:t>
+              <a:t>Custom pipeline orchestrator</a:t>
             </a:r>
             <a:endParaRPr lang="en-US" sz="850" dirty="0"/>
           </a:p>
@@ -20235,7 +20215,7 @@
                 <a:ea typeface="Calibri" pitchFamily="34" charset="-122"/>
                 <a:cs typeface="Calibri" pitchFamily="34" charset="-120"/>
               </a:rPr>
-              <a:t>ADO client: ado_client.py</a:t>
+              <a:t>ADO client for PR creation</a:t>
             </a:r>
             <a:endParaRPr lang="en-US" sz="850" dirty="0"/>
           </a:p>
@@ -20255,7 +20235,7 @@
                 <a:ea typeface="Calibri" pitchFamily="34" charset="-122"/>
                 <a:cs typeface="Calibri" pitchFamily="34" charset="-120"/>
               </a:rPr>
-              <a:t>(175 lines — PR + WI update)</a:t>
+              <a:t>and work item updates</a:t>
             </a:r>
             <a:endParaRPr lang="en-US" sz="850" dirty="0"/>
           </a:p>
@@ -20275,7 +20255,7 @@
                 <a:ea typeface="Calibri" pitchFamily="34" charset="-122"/>
                 <a:cs typeface="Calibri" pitchFamily="34" charset="-120"/>
               </a:rPr>
-              <a:t>Blob state sync (116 lines)</a:t>
+              <a:t>Blob state sync for persistence</a:t>
             </a:r>
             <a:endParaRPr lang="en-US" sz="850" dirty="0"/>
           </a:p>
@@ -20344,7 +20324,7 @@
                 <a:ea typeface="Calibri" pitchFamily="34" charset="-122"/>
                 <a:cs typeface="Calibri" pitchFamily="34" charset="-120"/>
               </a:rPr>
-              <a:t>Effort: 355 lines orchestrator</a:t>
+              <a:t>Effort: Medium (custom pipeline)</a:t>
             </a:r>
             <a:endParaRPr lang="en-US" sz="850" dirty="0"/>
           </a:p>
@@ -20690,7 +20670,7 @@
                 <a:ea typeface="Calibri" pitchFamily="34" charset="-122"/>
                 <a:cs typeface="Calibri" pitchFamily="34" charset="-120"/>
               </a:rPr>
-              <a:t>Custom pipeline.py — 248 lines</a:t>
+              <a:t>Custom pipeline orchestrator (High effort)</a:t>
             </a:r>
             <a:endParaRPr lang="en-US" sz="850" dirty="0"/>
           </a:p>
@@ -20788,7 +20768,7 @@
                 <a:ea typeface="Calibri" pitchFamily="34" charset="-122"/>
                 <a:cs typeface="Calibri" pitchFamily="34" charset="-120"/>
               </a:rPr>
-              <a:t>TOML declarative — 525 lines</a:t>
+              <a:t>TOML declarative (Low effort)</a:t>
             </a:r>
             <a:endParaRPr lang="en-US" sz="850" dirty="0"/>
           </a:p>
@@ -20827,7 +20807,7 @@
                 <a:ea typeface="Calibri" pitchFamily="34" charset="-122"/>
                 <a:cs typeface="Calibri" pitchFamily="34" charset="-120"/>
               </a:rPr>
-              <a:t>Python classes — 695 lines</a:t>
+              <a:t>Python classes (High effort)</a:t>
             </a:r>
             <a:endParaRPr lang="en-US" sz="850" dirty="0"/>
           </a:p>
@@ -20964,7 +20944,7 @@
                 <a:ea typeface="Calibri" pitchFamily="34" charset="-122"/>
                 <a:cs typeface="Calibri" pitchFamily="34" charset="-120"/>
               </a:rPr>
-              <a:t>Custom compressor — 108 lines</a:t>
+              <a:t>Custom compressor (High effort)</a:t>
             </a:r>
             <a:endParaRPr lang="en-US" sz="850" dirty="0"/>
           </a:p>
@@ -21101,7 +21081,7 @@
                 <a:ea typeface="Calibri" pitchFamily="34" charset="-122"/>
                 <a:cs typeface="Calibri" pitchFamily="34" charset="-120"/>
               </a:rPr>
-              <a:t>Custom chunker — 131 lines</a:t>
+              <a:t>Custom chunker (Medium effort)</a:t>
             </a:r>
             <a:endParaRPr lang="en-US" sz="850" dirty="0"/>
           </a:p>
@@ -21238,7 +21218,7 @@
                 <a:ea typeface="Calibri" pitchFamily="34" charset="-122"/>
                 <a:cs typeface="Calibri" pitchFamily="34" charset="-120"/>
               </a:rPr>
-              <a:t>Custom estimator — 56 lines</a:t>
+              <a:t>Custom token estimator (Medium effort)</a:t>
             </a:r>
             <a:endParaRPr lang="en-US" sz="850" dirty="0"/>
           </a:p>
@@ -21375,7 +21355,7 @@
                 <a:ea typeface="Calibri" pitchFamily="34" charset="-122"/>
                 <a:cs typeface="Calibri" pitchFamily="34" charset="-120"/>
               </a:rPr>
-              <a:t>Custom regex AST — 147 lines</a:t>
+              <a:t>Custom regex AST parser (High effort)</a:t>
             </a:r>
             <a:endParaRPr lang="en-US" sz="850" dirty="0"/>
           </a:p>
@@ -21512,7 +21492,7 @@
                 <a:ea typeface="Calibri" pitchFamily="34" charset="-122"/>
                 <a:cs typeface="Calibri" pitchFamily="34" charset="-120"/>
               </a:rPr>
-              <a:t>Custom file_tools — 104 lines</a:t>
+              <a:t>Custom file tools (Medium effort)</a:t>
             </a:r>
             <a:endParaRPr lang="en-US" sz="850" dirty="0"/>
           </a:p>
@@ -21649,7 +21629,7 @@
                 <a:ea typeface="Calibri" pitchFamily="34" charset="-122"/>
                 <a:cs typeface="Calibri" pitchFamily="34" charset="-120"/>
               </a:rPr>
-              <a:t>Custom test_runner — 134 lines</a:t>
+              <a:t>Custom test runner (Medium effort)</a:t>
             </a:r>
             <a:endParaRPr lang="en-US" sz="850" dirty="0"/>
           </a:p>
@@ -21923,7 +21903,7 @@
                 <a:ea typeface="Calibri" pitchFamily="34" charset="-122"/>
                 <a:cs typeface="Calibri" pitchFamily="34" charset="-120"/>
               </a:rPr>
-              <a:t>Custom scorer — 124 lines</a:t>
+              <a:t>Custom scorer (Medium effort)</a:t>
             </a:r>
             <a:endParaRPr lang="en-US" sz="850" dirty="0"/>
           </a:p>

</xml_diff>